<commit_message>
Fix admin date time zone; update whitepaper and deck for deployed CXD
</commit_message>
<xml_diff>
--- a/public/docs/CEXAID-Pitch-Deck.pptx
+++ b/public/docs/CEXAID-Pitch-Deck.pptx
@@ -1599,7 +1599,7 @@
           <a:p>
             <a:r>
               <a:rPr lang="en-US" dirty="0"/>
-              <a:t>Introduce CEXAID in one sentence. Say clearly that CXD has not launched and this is not an offer.</a:t>
+              <a:t>Introduce CEXAID in one sentence. Say clearly that the CXD contract is deployed but no sale is open, and that this is not an offer.</a:t>
             </a:r>
             <a:endParaRPr lang="en-US" dirty="0"/>
           </a:p>
@@ -2755,7 +2755,7 @@
                 <a:ea typeface="Inter" pitchFamily="34" charset="-122"/>
                 <a:cs typeface="Inter" pitchFamily="34" charset="-120"/>
               </a:rPr>
-              <a:t>Not an offer. CXD has not launched.</a:t>
+              <a:t>Not an offer. No CXD sale is open.</a:t>
             </a:r>
             <a:endParaRPr lang="en-US" sz="900" dirty="0"/>
           </a:p>
@@ -3688,7 +3688,7 @@
                 <a:ea typeface="Inter" pitchFamily="34" charset="-122"/>
                 <a:cs typeface="Inter" pitchFamily="34" charset="-120"/>
               </a:rPr>
-              <a:t>Phase 3 · Planned</a:t>
+              <a:t>Phase 3 · In progress</a:t>
             </a:r>
             <a:endParaRPr lang="en-US" sz="1100" dirty="0"/>
           </a:p>
@@ -3727,7 +3727,7 @@
                 <a:ea typeface="Inter" pitchFamily="34" charset="-122"/>
                 <a:cs typeface="Inter" pitchFamily="34" charset="-120"/>
               </a:rPr>
-              <a:t>Testnet and audit</a:t>
+              <a:t>Contract, vesting, audit</a:t>
             </a:r>
             <a:endParaRPr lang="en-US" sz="1600" dirty="0"/>
           </a:p>
@@ -3766,7 +3766,7 @@
                 <a:ea typeface="Inter" pitchFamily="34" charset="-122"/>
                 <a:cs typeface="Inter" pitchFamily="34" charset="-120"/>
               </a:rPr>
-              <a:t>Token and vesting contracts on testnet; independent audit</a:t>
+              <a:t>CXD contract live on BNB Chain; vesting contracts; independent audit</a:t>
             </a:r>
             <a:endParaRPr lang="en-US" sz="1200" dirty="0"/>
           </a:p>
@@ -3869,7 +3869,7 @@
                 <a:ea typeface="Inter" pitchFamily="34" charset="-122"/>
                 <a:cs typeface="Inter" pitchFamily="34" charset="-120"/>
               </a:rPr>
-              <a:t>Token launch</a:t>
+              <a:t>Distribution</a:t>
             </a:r>
             <a:endParaRPr lang="en-US" sz="1600" dirty="0"/>
           </a:p>
@@ -3908,7 +3908,7 @@
                 <a:ea typeface="Inter" pitchFamily="34" charset="-122"/>
                 <a:cs typeface="Inter" pitchFamily="34" charset="-120"/>
               </a:rPr>
-              <a:t>TGE after audit and legal review; liquidity and listings</a:t>
+              <a:t>Allocation schedule after audit and legal review; liquidity and listings</a:t>
             </a:r>
             <a:endParaRPr lang="en-US" sz="1200" dirty="0"/>
           </a:p>
@@ -4283,7 +4283,7 @@
                 <a:ea typeface="Inter" pitchFamily="34" charset="-122"/>
                 <a:cs typeface="Inter" pitchFamily="34" charset="-120"/>
               </a:rPr>
-              <a:t>Token not launched</a:t>
+              <a:t>Early stage</a:t>
             </a:r>
             <a:endParaRPr lang="en-US" sz="1600" dirty="0"/>
           </a:p>
@@ -4325,7 +4325,7 @@
                 <a:ea typeface="Inter" pitchFamily="34" charset="-122"/>
                 <a:cs typeface="Inter" pitchFamily="34" charset="-120"/>
               </a:rPr>
-              <a:t>CXD does not exist yet. The plan may change, be delayed or be cancelled.</a:t>
+              <a:t>The CXD contract is deployed but no sale or listing is open. The plan may change, be delayed or be cancelled.</a:t>
             </a:r>
             <a:endParaRPr lang="en-US" sz="1400" dirty="0"/>
           </a:p>
@@ -4458,7 +4458,7 @@
                 <a:ea typeface="Inter" pitchFamily="34" charset="-122"/>
                 <a:cs typeface="Inter" pitchFamily="34" charset="-120"/>
               </a:rPr>
-              <a:t>Sale contracts are tested but not yet independently audited. During a sale, funds sit in CEXAID's treasury wallet.</a:t>
+              <a:t>Sale and token contracts are tested but not yet independently audited. During a sale, funds sit in CEXAID's treasury wallet.</a:t>
             </a:r>
             <a:endParaRPr lang="en-US" sz="1400" dirty="0"/>
           </a:p>
@@ -5149,7 +5149,7 @@
                 <a:ea typeface="Inter" pitchFamily="34" charset="-122"/>
                 <a:cs typeface="Inter" pitchFamily="34" charset="-120"/>
               </a:rPr>
-              <a:t>This deck is for information only. It is not an offer to sell or a solicitation to buy any token or security, and not financial or legal advice. CXD has not launched. Figures are plans and may change.</a:t>
+              <a:t>This deck is for information only. It is not an offer to sell or a solicitation to buy any token or security, and not financial or legal advice. No CXD sale is open. Figures are plans and may change.</a:t>
             </a:r>
             <a:endParaRPr lang="en-US" sz="1100" dirty="0"/>
           </a:p>
@@ -7635,7 +7635,7 @@
                 <a:ea typeface="Inter" pitchFamily="34" charset="-122"/>
                 <a:cs typeface="Inter" pitchFamily="34" charset="-120"/>
               </a:rPr>
-              <a:t>CXD: planned utility</a:t>
+              <a:t>CXD: utility token</a:t>
             </a:r>
             <a:endParaRPr lang="en-US" sz="3000" dirty="0"/>
           </a:p>
@@ -8206,7 +8206,7 @@
                 <a:ea typeface="Inter" pitchFamily="34" charset="-122"/>
                 <a:cs typeface="Inter" pitchFamily="34" charset="-120"/>
               </a:rPr>
-              <a:t>CXD gives no ownership of CEXAID, no revenue share and no promise of profit. Chain to be announced.</a:t>
+              <a:t>CXD gives no ownership of CEXAID, no revenue share and no promise of profit. Deployed on BNB Chain (BEP20); contract verified on BscScan.</a:t>
             </a:r>
             <a:endParaRPr lang="en-US" sz="1400" dirty="0"/>
           </a:p>

</xml_diff>